<commit_message>
docs: add benchmark-grounded GAC aha example
</commit_message>
<xml_diff>
--- a/paper/slides/compiling-recurrent-agent-workflows-into-guarded-programs-detailed.pptx
+++ b/paper/slides/compiling-recurrent-agent-workflows-into-guarded-programs-detailed.pptx
@@ -14044,7 +14044,7 @@
                 <a:ea typeface="Cambria"/>
                 <a:cs typeface="Cambria"/>
               </a:rPr>
-              <a:t>Provenance succeeds; certification does not</a:t>
+              <a:t>Replay passes; the gate still refuses</a:t>
             </a:r>
           </a:p>
         </p:txBody>
@@ -14095,7 +14095,7 @@
                 <a:ea typeface="Calibri"/>
                 <a:cs typeface="Calibri"/>
               </a:rPr>
-              <a:t>Recurrence is fragmented: 714 candidate families exist, only 32 have support of at least five, and the best reaches 26 groups.</a:t>
+              <a:t>One NESTFUL trace looks like an obvious macro:</a:t>
             </a:r>
           </a:p>
           <a:p xmlns:a="http://schemas.openxmlformats.org/drawingml/2006/main">
@@ -14117,7 +14117,7 @@
                 <a:ea typeface="Calibri"/>
                 <a:cs typeface="Calibri"/>
               </a:rPr>
-              <a:t>Of 32 attempted families, 12 synthesize. Their 36 held-out windows give 24 passes, 12 abstentions and zero wrong executions.</a:t>
+              <a:t>subtract(60,50) → divide(result,50) → multiply(result,100)</a:t>
             </a:r>
           </a:p>
           <a:p xmlns:a="http://schemas.openxmlformats.org/drawingml/2006/main">
@@ -14139,7 +14139,7 @@
                 <a:ea typeface="Calibri"/>
                 <a:cs typeface="Calibri"/>
               </a:rPr>
-              <a:t>Zero wrong does not certify the programs. The gate needs 92 zero-violation groups, so every family retires.</a:t>
+              <a:t>Grounded, executable, and recurrent at the raw sequence level (33 records).</a:t>
             </a:r>
           </a:p>
         </p:txBody>
@@ -14234,7 +14234,7 @@
                 <a:ea typeface="Calibri"/>
                 <a:cs typeface="Calibri"/>
               </a:rPr>
-              <a:t>A scientifically useful negative result. </a:t>
+              <a:t>Naive rule: recurrence + replay → ship.</a:t>
             </a:r>
             <a:r>
               <a:rPr sz="1200">
@@ -14245,7 +14245,7 @@
                 <a:ea typeface="Calibri"/>
                 <a:cs typeface="Calibri"/>
               </a:rPr>
-              <a:t>It is what distinguishes a guarded compiler from a recurrence-only macro miner — and it exposes the data requirement instead of hiding it in a heuristic.</a:t>
+              <a:t>GAC: 26 groups &lt; 92 required → 0 certifiable families → RETIRE to baseline.</a:t>
             </a:r>
           </a:p>
         </p:txBody>
@@ -14353,7 +14353,7 @@
                 <a:ea typeface="Cambria"/>
                 <a:cs typeface="Cambria"/>
               </a:rPr>
-              <a:t>1,207 / 1,415</a:t>
+              <a:t>5,531 / 5,746</a:t>
             </a:r>
           </a:p>
         </p:txBody>
@@ -14401,7 +14401,7 @@
                 <a:ea typeface="Calibri"/>
                 <a:cs typeface="Calibri"/>
               </a:rPr>
-              <a:t>complete groundable windows (85.3%)</a:t>
+              <a:t>candidate producers (96.3%)</a:t>
             </a:r>
           </a:p>
         </p:txBody>
@@ -14493,7 +14493,7 @@
                 <a:ea typeface="Cambria"/>
                 <a:cs typeface="Cambria"/>
               </a:rPr>
-              <a:t>12 / 32</a:t>
+              <a:t>33</a:t>
             </a:r>
           </a:p>
         </p:txBody>
@@ -14541,7 +14541,7 @@
                 <a:ea typeface="Calibri"/>
                 <a:cs typeface="Calibri"/>
               </a:rPr>
-              <a:t>families synthesized</a:t>
+              <a:t>raw sequence support</a:t>
             </a:r>
           </a:p>
         </p:txBody>
@@ -14681,7 +14681,7 @@
                 <a:ea typeface="Calibri"/>
                 <a:cs typeface="Calibri"/>
               </a:rPr>
-              <a:t>held-out pass / abstain / wrong</a:t>
+              <a:t>replay pass / abstain / wrong</a:t>
             </a:r>
           </a:p>
         </p:txBody>
@@ -14773,7 +14773,7 @@
                 <a:ea typeface="Cambria"/>
                 <a:cs typeface="Cambria"/>
               </a:rPr>
-              <a:t>0</a:t>
+              <a:t>26 / 92</a:t>
             </a:r>
           </a:p>
         </p:txBody>
@@ -14821,7 +14821,7 @@
                 <a:ea typeface="Calibri"/>
                 <a:cs typeface="Calibri"/>
               </a:rPr>
-              <a:t>certifiable families</a:t>
+              <a:t>best family / gate minimum</a:t>
             </a:r>
           </a:p>
         </p:txBody>

</xml_diff>

<commit_message>
docs: strengthen GAC introduction example
</commit_message>
<xml_diff>
--- a/paper/slides/compiling-recurrent-agent-workflows-into-guarded-programs-detailed.pptx
+++ b/paper/slides/compiling-recurrent-agent-workflows-into-guarded-programs-detailed.pptx
@@ -13999,7 +13999,7 @@
                 <a:ea typeface="Calibri"/>
                 <a:cs typeface="Calibri"/>
               </a:rPr>
-              <a:t>RESULTS  ·  RQ1 AND RQ3  ·  §5.1  ·  TABLE 4</a:t>
+              <a:t>RESULTS  ·  RQ2  ·  §5.3  ·  TABLE 6</a:t>
             </a:r>
           </a:p>
         </p:txBody>
@@ -14044,7 +14044,7 @@
                 <a:ea typeface="Cambria"/>
                 <a:cs typeface="Cambria"/>
               </a:rPr>
-              <a:t>Replay passes; the gate still refuses</a:t>
+              <a:t>The full trace repeats; the boundary does not</a:t>
             </a:r>
           </a:p>
         </p:txBody>
@@ -14095,7 +14095,7 @@
                 <a:ea typeface="Calibri"/>
                 <a:cs typeface="Calibri"/>
               </a:rPr>
-              <a:t>One NESTFUL trace looks like an obvious macro:</a:t>
+              <a:t>A real GitHub trace looks like an obvious macro:</a:t>
             </a:r>
           </a:p>
           <a:p xmlns:a="http://schemas.openxmlformats.org/drawingml/2006/main">
@@ -14117,7 +14117,7 @@
                 <a:ea typeface="Calibri"/>
                 <a:cs typeface="Calibri"/>
               </a:rPr>
-              <a:t>subtract(60,50) → divide(result,50) → multiply(result,100)</a:t>
+              <a:t>issue #6602: record → labels → comments(limit=3)</a:t>
             </a:r>
           </a:p>
           <a:p xmlns:a="http://schemas.openxmlformats.org/drawingml/2006/main">
@@ -14139,7 +14139,7 @@
                 <a:ea typeface="Calibri"/>
                 <a:cs typeface="Calibri"/>
               </a:rPr>
-              <a:t>Grounded, executable, and recurrent at the raw sequence level (33 records).</a:t>
+              <a:t>45/45 tool replays; issue #6602 loses its Markdown URL.</a:t>
             </a:r>
           </a:p>
         </p:txBody>
@@ -14234,7 +14234,7 @@
                 <a:ea typeface="Calibri"/>
                 <a:cs typeface="Calibri"/>
               </a:rPr>
-              <a:t>Naive rule: recurrence + replay → ship.</a:t>
+              <a:t>Naive rule: recurrence + replay + one request → ship.</a:t>
             </a:r>
             <a:r>
               <a:rPr sz="1200">
@@ -14245,7 +14245,7 @@
                 <a:ea typeface="Calibri"/>
                 <a:cs typeface="Calibri"/>
               </a:rPr>
-              <a:t>GAC: 26 groups &lt; 92 required → 0 certifiable families → RETIRE to baseline.</a:t>
+              <a:t>GAC: ungroundable comments limit → keep comments and rendering with the agent.</a:t>
             </a:r>
           </a:p>
         </p:txBody>
@@ -14353,7 +14353,7 @@
                 <a:ea typeface="Cambria"/>
                 <a:cs typeface="Cambria"/>
               </a:rPr>
-              <a:t>5,531 / 5,746</a:t>
+              <a:t>132</a:t>
             </a:r>
           </a:p>
         </p:txBody>
@@ -14401,7 +14401,7 @@
                 <a:ea typeface="Calibri"/>
                 <a:cs typeface="Calibri"/>
               </a:rPr>
-              <a:t>candidate producers (96.3%)</a:t>
+              <a:t>discovery traces</a:t>
             </a:r>
           </a:p>
         </p:txBody>
@@ -14493,7 +14493,7 @@
                 <a:ea typeface="Cambria"/>
                 <a:cs typeface="Cambria"/>
               </a:rPr>
-              <a:t>33</a:t>
+              <a:t>116</a:t>
             </a:r>
           </a:p>
         </p:txBody>
@@ -14541,7 +14541,7 @@
                 <a:ea typeface="Calibri"/>
                 <a:cs typeface="Calibri"/>
               </a:rPr>
-              <a:t>raw sequence support</a:t>
+              <a:t>full-candidate support windows</a:t>
             </a:r>
           </a:p>
         </p:txBody>
@@ -14633,7 +14633,7 @@
                 <a:ea typeface="Cambria"/>
                 <a:cs typeface="Cambria"/>
               </a:rPr>
-              <a:t>24 / 12 / 0</a:t>
+              <a:t>92 / 92</a:t>
             </a:r>
           </a:p>
         </p:txBody>
@@ -14681,7 +14681,7 @@
                 <a:ea typeface="Calibri"/>
                 <a:cs typeface="Calibri"/>
               </a:rPr>
-              <a:t>replay pass / abstain / wrong</a:t>
+              <a:t>GAC calibration groups</a:t>
             </a:r>
           </a:p>
         </p:txBody>
@@ -14773,7 +14773,7 @@
                 <a:ea typeface="Cambria"/>
                 <a:cs typeface="Cambria"/>
               </a:rPr>
-              <a:t>26 / 92</a:t>
+              <a:t>18 / 18</a:t>
             </a:r>
           </a:p>
         </p:txBody>
@@ -14821,7 +14821,7 @@
                 <a:ea typeface="Calibri"/>
                 <a:cs typeface="Calibri"/>
               </a:rPr>
-              <a:t>best family / gate minimum</a:t>
+              <a:t>checked-rendered answers</a:t>
             </a:r>
           </a:p>
         </p:txBody>

</xml_diff>